<commit_message>
Changé en Nom Prénom
</commit_message>
<xml_diff>
--- a/fichiers/presentation/PresSpe.pptx
+++ b/fichiers/presentation/PresSpe.pptx
@@ -9148,9 +9148,10 @@
           </a:p>
           <a:p>
             <a:r>
-              <a:rPr lang="fr-FR" dirty="0"/>
-              <a:t>HUMBERT Tanguy</a:t>
-            </a:r>
+              <a:rPr lang="fr-FR"/>
+              <a:t>NOM Prénom</a:t>
+            </a:r>
+            <a:endParaRPr lang="fr-FR" dirty="0"/>
           </a:p>
           <a:p>
             <a:endParaRPr lang="fr-FR" dirty="0"/>
@@ -9915,8 +9916,8 @@
           <a:chExt cx="0" cy="0"/>
         </a:xfrm>
       </p:grpSpPr>
-      <mc:AlternateContent xmlns:mc="http://schemas.openxmlformats.org/markup-compatibility/2006">
-        <mc:Choice xmlns:pslz="http://schemas.microsoft.com/office/powerpoint/2016/slidezoom" Requires="pslz">
+      <mc:AlternateContent xmlns:mc="http://schemas.openxmlformats.org/markup-compatibility/2006" xmlns:pslz="http://schemas.microsoft.com/office/powerpoint/2016/slidezoom">
+        <mc:Choice Requires="pslz">
           <p:graphicFrame>
             <p:nvGraphicFramePr>
               <p:cNvPr id="11" name="Zoom de diapositive 10">
@@ -9973,7 +9974,7 @@
             </a:graphic>
           </p:graphicFrame>
         </mc:Choice>
-        <mc:Fallback>
+        <mc:Fallback xmlns="">
           <p:pic>
             <p:nvPicPr>
               <p:cNvPr id="11" name="Zoom de diapositive 10">
@@ -9990,7 +9991,7 @@
               <p:nvPr/>
             </p:nvPicPr>
             <p:blipFill>
-              <a:blip r:embed="rId2"/>
+              <a:blip r:embed="rId4"/>
               <a:stretch>
                 <a:fillRect/>
               </a:stretch>

</xml_diff>